<commit_message>
Set the deck in Libre Franklin and fix the type hierarchy
Every level was Arial at one of two weights, with the three table sizes a
point apart, so the slides read as bold body text rather than typeset pages.

Libre Franklin carries the display voice, slide titles go to 37pt with tighter
tracking, the table ramp opens to 17/13.5/11.5, and the column rule is lighter
than the title rule instead of matching it.
</commit_message>
<xml_diff>
--- a/Final DevOps Project/demo/slides.pptx
+++ b/Final DevOps Project/demo/slides.pptx
@@ -1690,7 +1690,7 @@
           <a:lstStyle>
             <a:lvl1pPr algn="l" indent="0" marL="0">
               <a:buNone/>
-              <a:defRPr lang="en-US" sz="3000" b="1" spc="-40" kern="0" dirty="0">
+              <a:defRPr lang="en-US" sz="3700" b="1" spc="-90" kern="0" dirty="0">
                 <a:solidFill>
                   <a:srgbClr val="14191B"/>
                 </a:solidFill>
@@ -1701,7 +1701,7 @@
             <a:pPr algn="l" indent="0" marL="0">
               <a:buNone/>
             </a:pPr>
-            <a:endParaRPr lang="en-US" sz="3000" dirty="0"/>
+            <a:endParaRPr lang="en-US" sz="3700" dirty="0"/>
           </a:p>
         </p:txBody>
       </p:sp>
@@ -2187,36 +2187,36 @@
           <a:p>
             <a:pPr indent="0" marL="0">
               <a:lnSpc>
-                <a:spcPct val="95000"/>
+                <a:spcPct val="92000"/>
               </a:lnSpc>
               <a:buNone/>
             </a:pPr>
             <a:r>
-              <a:rPr lang="en-US" sz="5400" b="1" spc="-160" kern="0" dirty="0">
+              <a:rPr lang="en-US" sz="6000" b="1" spc="-220" kern="0" dirty="0">
                 <a:solidFill>
                   <a:srgbClr val="FFFFFF"/>
                 </a:solidFill>
               </a:rPr>
               <a:t>Issue Tracker,</a:t>
             </a:r>
-            <a:endParaRPr lang="en-US" sz="5400" dirty="0"/>
+            <a:endParaRPr lang="en-US" sz="6000" dirty="0"/>
           </a:p>
           <a:p>
             <a:pPr indent="0" marL="0">
               <a:lnSpc>
-                <a:spcPct val="95000"/>
+                <a:spcPct val="92000"/>
               </a:lnSpc>
               <a:buNone/>
             </a:pPr>
             <a:r>
-              <a:rPr lang="en-US" sz="5400" b="1" spc="-160" kern="0" dirty="0">
+              <a:rPr lang="en-US" sz="6000" b="1" spc="-220" kern="0" dirty="0">
                 <a:solidFill>
                   <a:srgbClr val="FFFFFF"/>
                 </a:solidFill>
               </a:rPr>
               <a:t>end to end</a:t>
             </a:r>
-            <a:endParaRPr lang="en-US" sz="5400" dirty="0"/>
+            <a:endParaRPr lang="en-US" sz="6000" dirty="0"/>
           </a:p>
         </p:txBody>
       </p:sp>
@@ -2660,14 +2660,14 @@
               <a:buNone/>
             </a:pPr>
             <a:r>
-              <a:rPr lang="en-US" sz="3000" b="1" spc="-40" kern="0" dirty="0">
+              <a:rPr lang="en-US" sz="3700" b="1" spc="-90" kern="0" dirty="0">
                 <a:solidFill>
                   <a:srgbClr val="14191B"/>
                 </a:solidFill>
               </a:rPr>
               <a:t>Observability</a:t>
             </a:r>
-            <a:endParaRPr lang="en-US" sz="3000" dirty="0"/>
+            <a:endParaRPr lang="en-US" sz="3700" dirty="0"/>
           </a:p>
         </p:txBody>
       </p:sp>
@@ -2719,19 +2719,19 @@
           <a:p>
             <a:pPr indent="0" marL="0">
               <a:lnSpc>
-                <a:spcPct val="105000"/>
+                <a:spcPct val="103000"/>
               </a:lnSpc>
               <a:buNone/>
             </a:pPr>
             <a:r>
-              <a:rPr lang="en-US" sz="2100" b="1" spc="-40" kern="0" dirty="0">
+              <a:rPr lang="en-US" sz="2400" b="1" spc="-70" kern="0" dirty="0">
                 <a:solidFill>
                   <a:srgbClr val="14191B"/>
                 </a:solidFill>
               </a:rPr>
               <a:t>The autoscaler and the monitoring are designed together: neither has to know how many replicas there will be.</a:t>
             </a:r>
-            <a:endParaRPr lang="en-US" sz="2100" dirty="0"/>
+            <a:endParaRPr lang="en-US" sz="2400" dirty="0"/>
           </a:p>
         </p:txBody>
       </p:sp>
@@ -2785,7 +2785,7 @@
               <a:buNone/>
             </a:pPr>
             <a:r>
-              <a:rPr lang="en-US" sz="1350" b="1" dirty="0">
+              <a:rPr lang="en-US" sz="1350" b="1" spc="-20" kern="0" dirty="0">
                 <a:solidFill>
                   <a:srgbClr val="14191B"/>
                 </a:solidFill>
@@ -2885,7 +2885,7 @@
               <a:buNone/>
             </a:pPr>
             <a:r>
-              <a:rPr lang="en-US" sz="1350" b="1" dirty="0">
+              <a:rPr lang="en-US" sz="1350" b="1" spc="-20" kern="0" dirty="0">
                 <a:solidFill>
                   <a:srgbClr val="14191B"/>
                 </a:solidFill>
@@ -2985,7 +2985,7 @@
               <a:buNone/>
             </a:pPr>
             <a:r>
-              <a:rPr lang="en-US" sz="1350" b="1" dirty="0">
+              <a:rPr lang="en-US" sz="1350" b="1" spc="-20" kern="0" dirty="0">
                 <a:solidFill>
                   <a:srgbClr val="14191B"/>
                 </a:solidFill>
@@ -3085,7 +3085,7 @@
               <a:buNone/>
             </a:pPr>
             <a:r>
-              <a:rPr lang="en-US" sz="1350" b="1" dirty="0">
+              <a:rPr lang="en-US" sz="1350" b="1" spc="-20" kern="0" dirty="0">
                 <a:solidFill>
                   <a:srgbClr val="14191B"/>
                 </a:solidFill>
@@ -3532,14 +3532,14 @@
               <a:buNone/>
             </a:pPr>
             <a:r>
-              <a:rPr lang="en-US" sz="3000" b="1" spc="-40" kern="0" dirty="0">
+              <a:rPr lang="en-US" sz="3700" b="1" spc="-90" kern="0" dirty="0">
                 <a:solidFill>
                   <a:srgbClr val="14191B"/>
                 </a:solidFill>
               </a:rPr>
               <a:t>GitOps</a:t>
             </a:r>
-            <a:endParaRPr lang="en-US" sz="3000" dirty="0"/>
+            <a:endParaRPr lang="en-US" sz="3700" dirty="0"/>
           </a:p>
         </p:txBody>
       </p:sp>
@@ -3630,19 +3630,19 @@
           <a:p>
             <a:pPr indent="0" marL="0">
               <a:lnSpc>
-                <a:spcPct val="105000"/>
+                <a:spcPct val="103000"/>
               </a:lnSpc>
               <a:buNone/>
             </a:pPr>
             <a:r>
-              <a:rPr lang="en-US" sz="2300" b="1" spc="-50" kern="0" dirty="0">
+              <a:rPr lang="en-US" sz="2600" b="1" spc="-90" kern="0" dirty="0">
                 <a:solidFill>
                   <a:srgbClr val="14191B"/>
                 </a:solidFill>
               </a:rPr>
               <a:t>GitOps and an autoscaler disagree about who owns the replica count.</a:t>
             </a:r>
-            <a:endParaRPr lang="en-US" sz="2300" dirty="0"/>
+            <a:endParaRPr lang="en-US" sz="2600" dirty="0"/>
           </a:p>
         </p:txBody>
       </p:sp>
@@ -4021,14 +4021,14 @@
               <a:buNone/>
             </a:pPr>
             <a:r>
-              <a:rPr lang="en-US" sz="3000" b="1" spc="-40" kern="0" dirty="0">
+              <a:rPr lang="en-US" sz="3700" b="1" spc="-90" kern="0" dirty="0">
                 <a:solidFill>
                   <a:srgbClr val="14191B"/>
                 </a:solidFill>
               </a:rPr>
               <a:t>Troubleshooting drill</a:t>
             </a:r>
-            <a:endParaRPr lang="en-US" sz="3000" dirty="0"/>
+            <a:endParaRPr lang="en-US" sz="3700" dirty="0"/>
           </a:p>
         </p:txBody>
       </p:sp>
@@ -5043,14 +5043,14 @@
               <a:buNone/>
             </a:pPr>
             <a:r>
-              <a:rPr lang="en-US" sz="3000" b="1" spc="-40" kern="0" dirty="0">
+              <a:rPr lang="en-US" sz="3700" b="1" spc="-90" kern="0" dirty="0">
                 <a:solidFill>
                   <a:srgbClr val="FFFFFF"/>
                 </a:solidFill>
               </a:rPr>
               <a:t>What it taught</a:t>
             </a:r>
-            <a:endParaRPr lang="en-US" sz="3000" dirty="0"/>
+            <a:endParaRPr lang="en-US" sz="3700" dirty="0"/>
           </a:p>
         </p:txBody>
       </p:sp>
@@ -5603,14 +5603,14 @@
               <a:buNone/>
             </a:pPr>
             <a:r>
-              <a:rPr lang="en-US" sz="3000" b="1" spc="-40" kern="0" dirty="0">
+              <a:rPr lang="en-US" sz="3700" b="1" spc="-90" kern="0" dirty="0">
                 <a:solidFill>
                   <a:srgbClr val="14191B"/>
                 </a:solidFill>
               </a:rPr>
               <a:t>What it is</a:t>
             </a:r>
-            <a:endParaRPr lang="en-US" sz="3000" dirty="0"/>
+            <a:endParaRPr lang="en-US" sz="3700" dirty="0"/>
           </a:p>
         </p:txBody>
       </p:sp>
@@ -5662,19 +5662,19 @@
           <a:p>
             <a:pPr indent="0" marL="0">
               <a:lnSpc>
-                <a:spcPct val="105000"/>
+                <a:spcPct val="103000"/>
               </a:lnSpc>
               <a:buNone/>
             </a:pPr>
             <a:r>
-              <a:rPr lang="en-US" sz="2400" b="1" spc="-50" kern="0" dirty="0">
+              <a:rPr lang="en-US" sz="2700" b="1" spc="-90" kern="0" dirty="0">
                 <a:solidFill>
                   <a:srgbClr val="14191B"/>
                 </a:solidFill>
               </a:rPr>
               <a:t>The application is deliberately small so the system around it can be the subject.</a:t>
             </a:r>
-            <a:endParaRPr lang="en-US" sz="2400" dirty="0"/>
+            <a:endParaRPr lang="en-US" sz="2700" dirty="0"/>
           </a:p>
         </p:txBody>
       </p:sp>
@@ -6386,14 +6386,14 @@
               <a:buNone/>
             </a:pPr>
             <a:r>
-              <a:rPr lang="en-US" sz="3000" b="1" spc="-40" kern="0" dirty="0">
+              <a:rPr lang="en-US" sz="3700" b="1" spc="-90" kern="0" dirty="0">
                 <a:solidFill>
                   <a:srgbClr val="14191B"/>
                 </a:solidFill>
               </a:rPr>
               <a:t>Architecture</a:t>
             </a:r>
-            <a:endParaRPr lang="en-US" sz="3000" dirty="0"/>
+            <a:endParaRPr lang="en-US" sz="3700" dirty="0"/>
           </a:p>
         </p:txBody>
       </p:sp>
@@ -7620,14 +7620,14 @@
               <a:buNone/>
             </a:pPr>
             <a:r>
-              <a:rPr lang="en-US" sz="3000" b="1" spc="-40" kern="0" dirty="0">
+              <a:rPr lang="en-US" sz="3700" b="1" spc="-90" kern="0" dirty="0">
                 <a:solidFill>
                   <a:srgbClr val="14191B"/>
                 </a:solidFill>
               </a:rPr>
               <a:t>Stack</a:t>
             </a:r>
-            <a:endParaRPr lang="en-US" sz="3000" dirty="0"/>
+            <a:endParaRPr lang="en-US" sz="3700" dirty="0"/>
           </a:p>
         </p:txBody>
       </p:sp>
@@ -7773,17 +7773,17 @@
         <p:spPr>
           <a:xfrm>
             <a:off x="731520" y="1755648"/>
-            <a:ext cx="10698480" cy="12802"/>
+            <a:ext cx="10698480" cy="7315"/>
           </a:xfrm>
           <a:prstGeom prst="rect">
             <a:avLst/>
           </a:prstGeom>
           <a:solidFill>
-            <a:srgbClr val="14191B"/>
+            <a:srgbClr val="9DAEB3"/>
           </a:solidFill>
           <a:ln w="12700">
             <a:solidFill>
-              <a:srgbClr val="14191B"/>
+              <a:srgbClr val="9DAEB3"/>
             </a:solidFill>
             <a:prstDash val="solid"/>
           </a:ln>
@@ -7814,14 +7814,14 @@
               <a:buNone/>
             </a:pPr>
             <a:r>
-              <a:rPr lang="en-US" sz="1450" b="1" dirty="0">
+              <a:rPr lang="en-US" sz="1700" b="1" spc="-30" kern="0" dirty="0">
                 <a:solidFill>
                   <a:srgbClr val="14191B"/>
                 </a:solidFill>
               </a:rPr>
               <a:t>Application</a:t>
             </a:r>
-            <a:endParaRPr lang="en-US" sz="1450" dirty="0"/>
+            <a:endParaRPr lang="en-US" sz="1700" dirty="0"/>
           </a:p>
         </p:txBody>
       </p:sp>
@@ -7850,14 +7850,14 @@
               <a:buNone/>
             </a:pPr>
             <a:r>
-              <a:rPr lang="en-US" sz="1300" dirty="0">
+              <a:rPr lang="en-US" sz="1350" dirty="0">
                 <a:solidFill>
                   <a:srgbClr val="14191B"/>
                 </a:solidFill>
               </a:rPr>
               <a:t>React 18 · Vite</a:t>
             </a:r>
-            <a:endParaRPr lang="en-US" sz="1300" dirty="0"/>
+            <a:endParaRPr lang="en-US" sz="1350" dirty="0"/>
           </a:p>
         </p:txBody>
       </p:sp>
@@ -7886,14 +7886,14 @@
               <a:buNone/>
             </a:pPr>
             <a:r>
-              <a:rPr lang="en-US" sz="1250" dirty="0">
-                <a:solidFill>
-                  <a:srgbClr val="4A5861"/>
+              <a:rPr lang="en-US" sz="1150" dirty="0">
+                <a:solidFill>
+                  <a:srgbClr val="5C6E76"/>
                 </a:solidFill>
               </a:rPr>
               <a:t>FastAPI · SQLAlchemy 2 · Alembic · PostgreSQL 16</a:t>
             </a:r>
-            <a:endParaRPr lang="en-US" sz="1250" dirty="0"/>
+            <a:endParaRPr lang="en-US" sz="1150" dirty="0"/>
           </a:p>
         </p:txBody>
       </p:sp>
@@ -7947,14 +7947,14 @@
               <a:buNone/>
             </a:pPr>
             <a:r>
-              <a:rPr lang="en-US" sz="1450" b="1" dirty="0">
+              <a:rPr lang="en-US" sz="1700" b="1" spc="-30" kern="0" dirty="0">
                 <a:solidFill>
                   <a:srgbClr val="14191B"/>
                 </a:solidFill>
               </a:rPr>
               <a:t>Containers</a:t>
             </a:r>
-            <a:endParaRPr lang="en-US" sz="1450" dirty="0"/>
+            <a:endParaRPr lang="en-US" sz="1700" dirty="0"/>
           </a:p>
         </p:txBody>
       </p:sp>
@@ -7983,14 +7983,14 @@
               <a:buNone/>
             </a:pPr>
             <a:r>
-              <a:rPr lang="en-US" sz="1300" dirty="0">
+              <a:rPr lang="en-US" sz="1350" dirty="0">
                 <a:solidFill>
                   <a:srgbClr val="14191B"/>
                 </a:solidFill>
               </a:rPr>
               <a:t>Multi-stage</a:t>
             </a:r>
-            <a:endParaRPr lang="en-US" sz="1300" dirty="0"/>
+            <a:endParaRPr lang="en-US" sz="1350" dirty="0"/>
           </a:p>
         </p:txBody>
       </p:sp>
@@ -8019,14 +8019,14 @@
               <a:buNone/>
             </a:pPr>
             <a:r>
-              <a:rPr lang="en-US" sz="1250" dirty="0">
-                <a:solidFill>
-                  <a:srgbClr val="4A5861"/>
+              <a:rPr lang="en-US" sz="1150" dirty="0">
+                <a:solidFill>
+                  <a:srgbClr val="5C6E76"/>
                 </a:solidFill>
               </a:rPr>
               <a:t>non-root UIDs · nginx-unprivileged · Docker Compose</a:t>
             </a:r>
-            <a:endParaRPr lang="en-US" sz="1250" dirty="0"/>
+            <a:endParaRPr lang="en-US" sz="1150" dirty="0"/>
           </a:p>
         </p:txBody>
       </p:sp>
@@ -8080,14 +8080,14 @@
               <a:buNone/>
             </a:pPr>
             <a:r>
-              <a:rPr lang="en-US" sz="1450" b="1" dirty="0">
+              <a:rPr lang="en-US" sz="1700" b="1" spc="-30" kern="0" dirty="0">
                 <a:solidFill>
                   <a:srgbClr val="14191B"/>
                 </a:solidFill>
               </a:rPr>
               <a:t>Pipeline</a:t>
             </a:r>
-            <a:endParaRPr lang="en-US" sz="1450" dirty="0"/>
+            <a:endParaRPr lang="en-US" sz="1700" dirty="0"/>
           </a:p>
         </p:txBody>
       </p:sp>
@@ -8116,14 +8116,14 @@
               <a:buNone/>
             </a:pPr>
             <a:r>
-              <a:rPr lang="en-US" sz="1300" dirty="0">
+              <a:rPr lang="en-US" sz="1350" dirty="0">
                 <a:solidFill>
                   <a:srgbClr val="14191B"/>
                 </a:solidFill>
               </a:rPr>
               <a:t>GitHub Actions</a:t>
             </a:r>
-            <a:endParaRPr lang="en-US" sz="1300" dirty="0"/>
+            <a:endParaRPr lang="en-US" sz="1350" dirty="0"/>
           </a:p>
         </p:txBody>
       </p:sp>
@@ -8152,14 +8152,14 @@
               <a:buNone/>
             </a:pPr>
             <a:r>
-              <a:rPr lang="en-US" sz="1250" dirty="0">
-                <a:solidFill>
-                  <a:srgbClr val="4A5861"/>
+              <a:rPr lang="en-US" sz="1150" dirty="0">
+                <a:solidFill>
+                  <a:srgbClr val="5C6E76"/>
                 </a:solidFill>
               </a:rPr>
               <a:t>GHCR · Trivy · Helm · kind inside the runner</a:t>
             </a:r>
-            <a:endParaRPr lang="en-US" sz="1250" dirty="0"/>
+            <a:endParaRPr lang="en-US" sz="1150" dirty="0"/>
           </a:p>
         </p:txBody>
       </p:sp>
@@ -8213,14 +8213,14 @@
               <a:buNone/>
             </a:pPr>
             <a:r>
-              <a:rPr lang="en-US" sz="1450" b="1" dirty="0">
+              <a:rPr lang="en-US" sz="1700" b="1" spc="-30" kern="0" dirty="0">
                 <a:solidFill>
                   <a:srgbClr val="14191B"/>
                 </a:solidFill>
               </a:rPr>
               <a:t>Cluster</a:t>
             </a:r>
-            <a:endParaRPr lang="en-US" sz="1450" dirty="0"/>
+            <a:endParaRPr lang="en-US" sz="1700" dirty="0"/>
           </a:p>
         </p:txBody>
       </p:sp>
@@ -8249,14 +8249,14 @@
               <a:buNone/>
             </a:pPr>
             <a:r>
-              <a:rPr lang="en-US" sz="1300" dirty="0">
+              <a:rPr lang="en-US" sz="1350" dirty="0">
                 <a:solidFill>
                   <a:srgbClr val="14191B"/>
                 </a:solidFill>
               </a:rPr>
               <a:t>Minikube</a:t>
             </a:r>
-            <a:endParaRPr lang="en-US" sz="1300" dirty="0"/>
+            <a:endParaRPr lang="en-US" sz="1350" dirty="0"/>
           </a:p>
         </p:txBody>
       </p:sp>
@@ -8285,14 +8285,14 @@
               <a:buNone/>
             </a:pPr>
             <a:r>
-              <a:rPr lang="en-US" sz="1250" dirty="0">
-                <a:solidFill>
-                  <a:srgbClr val="4A5861"/>
+              <a:rPr lang="en-US" sz="1150" dirty="0">
+                <a:solidFill>
+                  <a:srgbClr val="5C6E76"/>
                 </a:solidFill>
               </a:rPr>
               <a:t>ingress-nginx · metrics-server · one chart, three value files</a:t>
             </a:r>
-            <a:endParaRPr lang="en-US" sz="1250" dirty="0"/>
+            <a:endParaRPr lang="en-US" sz="1150" dirty="0"/>
           </a:p>
         </p:txBody>
       </p:sp>
@@ -8346,14 +8346,14 @@
               <a:buNone/>
             </a:pPr>
             <a:r>
-              <a:rPr lang="en-US" sz="1450" b="1" dirty="0">
+              <a:rPr lang="en-US" sz="1700" b="1" spc="-30" kern="0" dirty="0">
                 <a:solidFill>
                   <a:srgbClr val="14191B"/>
                 </a:solidFill>
               </a:rPr>
               <a:t>Operations</a:t>
             </a:r>
-            <a:endParaRPr lang="en-US" sz="1450" dirty="0"/>
+            <a:endParaRPr lang="en-US" sz="1700" dirty="0"/>
           </a:p>
         </p:txBody>
       </p:sp>
@@ -8382,14 +8382,14 @@
               <a:buNone/>
             </a:pPr>
             <a:r>
-              <a:rPr lang="en-US" sz="1300" dirty="0">
+              <a:rPr lang="en-US" sz="1350" dirty="0">
                 <a:solidFill>
                   <a:srgbClr val="14191B"/>
                 </a:solidFill>
               </a:rPr>
               <a:t>Prometheus</a:t>
             </a:r>
-            <a:endParaRPr lang="en-US" sz="1300" dirty="0"/>
+            <a:endParaRPr lang="en-US" sz="1350" dirty="0"/>
           </a:p>
         </p:txBody>
       </p:sp>
@@ -8418,14 +8418,14 @@
               <a:buNone/>
             </a:pPr>
             <a:r>
-              <a:rPr lang="en-US" sz="1250" dirty="0">
-                <a:solidFill>
-                  <a:srgbClr val="4A5861"/>
+              <a:rPr lang="en-US" sz="1150" dirty="0">
+                <a:solidFill>
+                  <a:srgbClr val="5C6E76"/>
                 </a:solidFill>
               </a:rPr>
               <a:t>Grafana · alert rules · Argo CD · Terraform for the network</a:t>
             </a:r>
-            <a:endParaRPr lang="en-US" sz="1250" dirty="0"/>
+            <a:endParaRPr lang="en-US" sz="1150" dirty="0"/>
           </a:p>
         </p:txBody>
       </p:sp>
@@ -8590,14 +8590,14 @@
               <a:buNone/>
             </a:pPr>
             <a:r>
-              <a:rPr lang="en-US" sz="3000" b="1" spc="-40" kern="0" dirty="0">
+              <a:rPr lang="en-US" sz="3700" b="1" spc="-90" kern="0" dirty="0">
                 <a:solidFill>
                   <a:srgbClr val="14191B"/>
                 </a:solidFill>
               </a:rPr>
               <a:t>The API</a:t>
             </a:r>
-            <a:endParaRPr lang="en-US" sz="3000" dirty="0"/>
+            <a:endParaRPr lang="en-US" sz="3700" dirty="0"/>
           </a:p>
         </p:txBody>
       </p:sp>
@@ -9787,19 +9787,19 @@
           <a:p>
             <a:pPr indent="0" marL="0">
               <a:lnSpc>
-                <a:spcPct val="110000"/>
+                <a:spcPct val="108000"/>
               </a:lnSpc>
               <a:buNone/>
             </a:pPr>
             <a:r>
-              <a:rPr lang="en-US" sz="1700" b="1" spc="-30" kern="0" dirty="0">
+              <a:rPr lang="en-US" sz="1900" b="1" spc="-50" kern="0" dirty="0">
                 <a:solidFill>
                   <a:srgbClr val="14191B"/>
                 </a:solidFill>
               </a:rPr>
               <a:t>A liveness probe that queried the database would restart a healthy Pod every time the database blinked.</a:t>
             </a:r>
-            <a:endParaRPr lang="en-US" sz="1700" dirty="0"/>
+            <a:endParaRPr lang="en-US" sz="1900" dirty="0"/>
           </a:p>
         </p:txBody>
       </p:sp>
@@ -9965,14 +9965,14 @@
               <a:buNone/>
             </a:pPr>
             <a:r>
-              <a:rPr lang="en-US" sz="3000" b="1" spc="-40" kern="0" dirty="0">
+              <a:rPr lang="en-US" sz="3700" b="1" spc="-90" kern="0" dirty="0">
                 <a:solidFill>
                   <a:srgbClr val="14191B"/>
                 </a:solidFill>
               </a:rPr>
               <a:t>Containers</a:t>
             </a:r>
-            <a:endParaRPr lang="en-US" sz="3000" dirty="0"/>
+            <a:endParaRPr lang="en-US" sz="3700" dirty="0"/>
           </a:p>
         </p:txBody>
       </p:sp>
@@ -10340,7 +10340,7 @@
               <a:buNone/>
             </a:pPr>
             <a:r>
-              <a:rPr lang="en-US" sz="1400" b="1" dirty="0">
+              <a:rPr lang="en-US" sz="1400" b="1" spc="-20" kern="0" dirty="0">
                 <a:solidFill>
                   <a:srgbClr val="14191B"/>
                 </a:solidFill>
@@ -10440,7 +10440,7 @@
               <a:buNone/>
             </a:pPr>
             <a:r>
-              <a:rPr lang="en-US" sz="1400" b="1" dirty="0">
+              <a:rPr lang="en-US" sz="1400" b="1" spc="-20" kern="0" dirty="0">
                 <a:solidFill>
                   <a:srgbClr val="14191B"/>
                 </a:solidFill>
@@ -10540,7 +10540,7 @@
               <a:buNone/>
             </a:pPr>
             <a:r>
-              <a:rPr lang="en-US" sz="1400" b="1" dirty="0">
+              <a:rPr lang="en-US" sz="1400" b="1" spc="-20" kern="0" dirty="0">
                 <a:solidFill>
                   <a:srgbClr val="14191B"/>
                 </a:solidFill>
@@ -10687,14 +10687,14 @@
               <a:buNone/>
             </a:pPr>
             <a:r>
-              <a:rPr lang="en-US" sz="3000" b="1" spc="-40" kern="0" dirty="0">
+              <a:rPr lang="en-US" sz="3700" b="1" spc="-90" kern="0" dirty="0">
                 <a:solidFill>
                   <a:srgbClr val="14191B"/>
                 </a:solidFill>
               </a:rPr>
               <a:t>The pipeline</a:t>
             </a:r>
-            <a:endParaRPr lang="en-US" sz="3000" dirty="0"/>
+            <a:endParaRPr lang="en-US" sz="3700" dirty="0"/>
           </a:p>
         </p:txBody>
       </p:sp>
@@ -10809,7 +10809,7 @@
               <a:buNone/>
             </a:pPr>
             <a:r>
-              <a:rPr lang="en-US" sz="1450" b="1" dirty="0">
+              <a:rPr lang="en-US" sz="1450" b="1" spc="-20" kern="0" dirty="0">
                 <a:solidFill>
                   <a:srgbClr val="14191B"/>
                 </a:solidFill>
@@ -10945,7 +10945,7 @@
               <a:buNone/>
             </a:pPr>
             <a:r>
-              <a:rPr lang="en-US" sz="1450" b="1" dirty="0">
+              <a:rPr lang="en-US" sz="1450" b="1" spc="-20" kern="0" dirty="0">
                 <a:solidFill>
                   <a:srgbClr val="14191B"/>
                 </a:solidFill>
@@ -11081,7 +11081,7 @@
               <a:buNone/>
             </a:pPr>
             <a:r>
-              <a:rPr lang="en-US" sz="1450" b="1" dirty="0">
+              <a:rPr lang="en-US" sz="1450" b="1" spc="-20" kern="0" dirty="0">
                 <a:solidFill>
                   <a:srgbClr val="14191B"/>
                 </a:solidFill>
@@ -11217,7 +11217,7 @@
               <a:buNone/>
             </a:pPr>
             <a:r>
-              <a:rPr lang="en-US" sz="1450" b="1" dirty="0">
+              <a:rPr lang="en-US" sz="1450" b="1" spc="-20" kern="0" dirty="0">
                 <a:solidFill>
                   <a:srgbClr val="14191B"/>
                 </a:solidFill>
@@ -11317,7 +11317,7 @@
               <a:buNone/>
             </a:pPr>
             <a:r>
-              <a:rPr lang="en-US" sz="1500" b="1" dirty="0">
+              <a:rPr lang="en-US" sz="1500" b="1" spc="-20" kern="0" dirty="0">
                 <a:solidFill>
                   <a:srgbClr val="14191B"/>
                 </a:solidFill>
@@ -11640,14 +11640,14 @@
               <a:buNone/>
             </a:pPr>
             <a:r>
-              <a:rPr lang="en-US" sz="3000" b="1" spc="-40" kern="0" dirty="0">
+              <a:rPr lang="en-US" sz="3700" b="1" spc="-90" kern="0" dirty="0">
                 <a:solidFill>
                   <a:srgbClr val="FFFFFF"/>
                 </a:solidFill>
               </a:rPr>
               <a:t>The gate</a:t>
             </a:r>
-            <a:endParaRPr lang="en-US" sz="3000" dirty="0"/>
+            <a:endParaRPr lang="en-US" sz="3700" dirty="0"/>
           </a:p>
         </p:txBody>
       </p:sp>
@@ -11699,19 +11699,19 @@
           <a:p>
             <a:pPr indent="0" marL="0">
               <a:lnSpc>
-                <a:spcPct val="105000"/>
+                <a:spcPct val="103000"/>
               </a:lnSpc>
               <a:buNone/>
             </a:pPr>
             <a:r>
-              <a:rPr lang="en-US" sz="2500" b="1" spc="-50" kern="0" dirty="0">
+              <a:rPr lang="en-US" sz="2800" b="1" spc="-90" kern="0" dirty="0">
                 <a:solidFill>
                   <a:srgbClr val="FFFFFF"/>
                 </a:solidFill>
               </a:rPr>
               <a:t>A scan that fails the build is only worth having if the fix is cheap.</a:t>
             </a:r>
-            <a:endParaRPr lang="en-US" sz="2500" dirty="0"/>
+            <a:endParaRPr lang="en-US" sz="2800" dirty="0"/>
           </a:p>
         </p:txBody>
       </p:sp>
@@ -12231,14 +12231,14 @@
               <a:buNone/>
             </a:pPr>
             <a:r>
-              <a:rPr lang="en-US" sz="3000" b="1" spc="-40" kern="0" dirty="0">
+              <a:rPr lang="en-US" sz="3700" b="1" spc="-90" kern="0" dirty="0">
                 <a:solidFill>
                   <a:srgbClr val="14191B"/>
                 </a:solidFill>
               </a:rPr>
               <a:t>Kubernetes and Helm</a:t>
             </a:r>
-            <a:endParaRPr lang="en-US" sz="3000" dirty="0"/>
+            <a:endParaRPr lang="en-US" sz="3700" dirty="0"/>
           </a:p>
         </p:txBody>
       </p:sp>
@@ -12925,19 +12925,19 @@
           <a:p>
             <a:pPr indent="0" marL="0">
               <a:lnSpc>
-                <a:spcPct val="105000"/>
+                <a:spcPct val="103000"/>
               </a:lnSpc>
               <a:buNone/>
             </a:pPr>
             <a:r>
-              <a:rPr lang="en-US" sz="1900" b="1" spc="-30" kern="0" dirty="0">
+              <a:rPr lang="en-US" sz="2200" b="1" spc="-60" kern="0" dirty="0">
                 <a:solidFill>
                   <a:srgbClr val="14191B"/>
                 </a:solidFill>
               </a:rPr>
               <a:t>Change the config and the Pods roll.</a:t>
             </a:r>
-            <a:endParaRPr lang="en-US" sz="1900" dirty="0"/>
+            <a:endParaRPr lang="en-US" sz="2200" dirty="0"/>
           </a:p>
         </p:txBody>
       </p:sp>
@@ -13200,7 +13200,7 @@
     </a:clrScheme>
     <a:fontScheme name="Issue Board Capstone">
       <a:majorFont>
-        <a:latin typeface="Arial"/>
+        <a:latin typeface="Libre Franklin"/>
         <a:ea typeface=""/>
         <a:cs typeface=""/>
         <a:font script="Jpan" typeface="游ゴシック Light"/>
@@ -13252,7 +13252,7 @@
         <a:font script="Tfng" typeface="Ebrima"/>
       </a:majorFont>
       <a:minorFont>
-        <a:latin typeface="Arial"/>
+        <a:latin typeface="Libre Franklin"/>
         <a:ea typeface=""/>
         <a:cs typeface=""/>
         <a:font script="Jpan" typeface="游ゴシック"/>

</xml_diff>